<commit_message>
Slide ChallengEat 8: aggiunto Andrea Severi tra i mentor Naturitalia
Co-Authored-By: Claude Sonnet 5.5 <noreply@anthropic.com>
Claude-Session: https://claude.ai/code/session_01MRJktvvjWbxjtNYhpM5dce
</commit_message>
<xml_diff>
--- a/slides/benvenuto.pptx
+++ b/slides/benvenuto.pptx
@@ -124,26 +124,26 @@
   <p:extLst>
     <p:ext uri="{521415D9-36F7-43E2-AB2F-B90AF26B5E84}">
       <p14:sectionLst xmlns:p14="http://schemas.microsoft.com/office/powerpoint/2010/main">
-        <p14:section name="Apertura" id="{509c0771-863a-b3c7-8506-bf71d6054aef}">
+        <p14:section name="Apertura" id="{88171379-a59d-5639-d9a6-d31e3d6c5499}">
           <p14:sldIdLst>
             <p14:sldId id="256"/>
           </p14:sldIdLst>
         </p14:section>
-        <p14:section name="Il percorso" id="{4c330bce-1c9a-49e3-7c85-b258b681318c}">
+        <p14:section name="Il percorso" id="{9492a6b6-48dc-a381-0846-6d4a975c5d0f}">
           <p14:sldIdLst>
             <p14:sldId id="257"/>
             <p14:sldId id="258"/>
             <p14:sldId id="259"/>
           </p14:sldIdLst>
         </p14:section>
-        <p14:section name="Calendario" id="{2cdbb5a7-2261-4216-9766-bfaae3f10aab}">
+        <p14:section name="Calendario" id="{da3f0a70-de16-d8b7-9cea-dd311316edf3}">
           <p14:sldIdLst>
             <p14:sldId id="260"/>
             <p14:sldId id="261"/>
             <p14:sldId id="262"/>
           </p14:sldIdLst>
         </p14:section>
-        <p14:section name="Lavoro in gruppo" id="{169f060d-772a-373a-94d0-1f1d3ef5cf68}">
+        <p14:section name="Lavoro in gruppo" id="{db6a5410-0c4f-9006-b7f8-363bce3e0b6c}">
           <p14:sldIdLst>
             <p14:sldId id="263"/>
             <p14:sldId id="264"/>
@@ -152,14 +152,14 @@
             <p14:sldId id="267"/>
           </p14:sldIdLst>
         </p14:section>
-        <p14:section name="La piattaforma" id="{b8d33478-6e4e-f98d-991a-45880a6403dc}">
+        <p14:section name="La piattaforma" id="{36eacc01-a44d-14fc-3173-c0d9359e525a}">
           <p14:sldIdLst>
             <p14:sldId id="268"/>
             <p14:sldId id="269"/>
             <p14:sldId id="270"/>
           </p14:sldIdLst>
         </p14:section>
-        <p14:section name="Il valore del percorso" id="{0c10bfac-6965-b95f-6c9a-8578a125fd0e}">
+        <p14:section name="Il valore del percorso" id="{9c31d94a-4bee-4fe9-19ce-e1d8acc99a70}">
           <p14:sldIdLst>
             <p14:sldId id="271"/>
             <p14:sldId id="272"/>
@@ -7095,7 +7095,7 @@
                   <a:schemeClr val="tx1"/>
                 </a:solidFill>
               </a:rPr>
-              <a:t>Mentor: Greta Gubellini e Andrea</a:t>
+              <a:t>Mentor: Greta Gubellini e Andrea Severi</a:t>
             </a:r>
             <a:endParaRPr lang="en-US" sz="1800" dirty="0"/>
           </a:p>

</xml_diff>

<commit_message>
Slide ChallengEat 8: sessione condivisa dalle 17:00 alle 18:30
Aggiornati benvenuto (HTML, PowerPoint, PDF) e i PDF delle sfide.

Co-Authored-By: Claude Sonnet 5.5 <noreply@anthropic.com>
Claude-Session: https://claude.ai/code/session_01MRJktvvjWbxjtNYhpM5dce
</commit_message>
<xml_diff>
--- a/slides/benvenuto.pptx
+++ b/slides/benvenuto.pptx
@@ -124,26 +124,26 @@
   <p:extLst>
     <p:ext uri="{521415D9-36F7-43E2-AB2F-B90AF26B5E84}">
       <p14:sectionLst xmlns:p14="http://schemas.microsoft.com/office/powerpoint/2010/main">
-        <p14:section name="Apertura" id="{88171379-a59d-5639-d9a6-d31e3d6c5499}">
+        <p14:section name="Apertura" id="{45b10f83-e064-4203-2da7-1b31b9889e61}">
           <p14:sldIdLst>
             <p14:sldId id="256"/>
           </p14:sldIdLst>
         </p14:section>
-        <p14:section name="Il percorso" id="{9492a6b6-48dc-a381-0846-6d4a975c5d0f}">
+        <p14:section name="Il percorso" id="{8a184de6-b502-bf21-0d25-5fd9356e93b3}">
           <p14:sldIdLst>
             <p14:sldId id="257"/>
             <p14:sldId id="258"/>
             <p14:sldId id="259"/>
           </p14:sldIdLst>
         </p14:section>
-        <p14:section name="Calendario" id="{da3f0a70-de16-d8b7-9cea-dd311316edf3}">
+        <p14:section name="Calendario" id="{c3c91e9f-f7e0-dfb5-eda8-838949015565}">
           <p14:sldIdLst>
             <p14:sldId id="260"/>
             <p14:sldId id="261"/>
             <p14:sldId id="262"/>
           </p14:sldIdLst>
         </p14:section>
-        <p14:section name="Lavoro in gruppo" id="{db6a5410-0c4f-9006-b7f8-363bce3e0b6c}">
+        <p14:section name="Lavoro in gruppo" id="{243660f5-1e72-a30c-3d9f-50cc1a5c30db}">
           <p14:sldIdLst>
             <p14:sldId id="263"/>
             <p14:sldId id="264"/>
@@ -152,14 +152,14 @@
             <p14:sldId id="267"/>
           </p14:sldIdLst>
         </p14:section>
-        <p14:section name="La piattaforma" id="{36eacc01-a44d-14fc-3173-c0d9359e525a}">
+        <p14:section name="La piattaforma" id="{7449b8dc-a2aa-be3b-2dae-e056a545759a}">
           <p14:sldIdLst>
             <p14:sldId id="268"/>
             <p14:sldId id="269"/>
             <p14:sldId id="270"/>
           </p14:sldIdLst>
         </p14:section>
-        <p14:section name="Il valore del percorso" id="{9c31d94a-4bee-4fe9-19ce-e1d8acc99a70}">
+        <p14:section name="Il valore del percorso" id="{7a54560c-7b57-29c6-f8a6-f8798df4bec2}">
           <p14:sldIdLst>
             <p14:sldId id="271"/>
             <p14:sldId id="272"/>
@@ -8799,7 +8799,7 @@
                   <a:schemeClr val="tx1"/>
                 </a:solidFill>
               </a:rPr>
-              <a:t>Sessione condivisa, 1 ora</a:t>
+              <a:t>Sessione condivisa, 1 ora e mezza</a:t>
             </a:r>
             <a:endParaRPr lang="en-US" sz="2400" dirty="0"/>
           </a:p>
@@ -8839,7 +8839,7 @@
                   <a:schemeClr val="tx1"/>
                 </a:solidFill>
               </a:rPr>
-              <a:t>Dalle 17:30 alle 18:30, tutti insieme</a:t>
+              <a:t>Dalle 17:00 alle 18:30, tutti insieme</a:t>
             </a:r>
             <a:endParaRPr lang="en-US" sz="1800" dirty="0"/>
           </a:p>
@@ -9477,7 +9477,7 @@
                   <a:schemeClr val="bg1"/>
                 </a:solidFill>
               </a:rPr>
-              <a:t>Sessione condivisa 17:30</a:t>
+              <a:t>Sessione condivisa 17:00</a:t>
             </a:r>
             <a:endParaRPr lang="en-US" sz="1200" dirty="0"/>
           </a:p>
@@ -9765,7 +9765,7 @@
                   <a:schemeClr val="bg1"/>
                 </a:solidFill>
               </a:rPr>
-              <a:t>Sessione condivisa 17:30</a:t>
+              <a:t>Sessione condivisa 17:00</a:t>
             </a:r>
             <a:endParaRPr lang="en-US" sz="1200" dirty="0"/>
           </a:p>
@@ -10053,7 +10053,7 @@
                   <a:schemeClr val="bg1"/>
                 </a:solidFill>
               </a:rPr>
-              <a:t>Sessione condivisa 17:30</a:t>
+              <a:t>Sessione condivisa 17:00</a:t>
             </a:r>
             <a:endParaRPr lang="en-US" sz="1200" dirty="0"/>
           </a:p>
@@ -10341,7 +10341,7 @@
                   <a:schemeClr val="bg1"/>
                 </a:solidFill>
               </a:rPr>
-              <a:t>Sessione condivisa 17:30</a:t>
+              <a:t>Sessione condivisa 17:00</a:t>
             </a:r>
             <a:endParaRPr lang="en-US" sz="1200" dirty="0"/>
           </a:p>
@@ -10629,7 +10629,7 @@
                   <a:schemeClr val="bg1"/>
                 </a:solidFill>
               </a:rPr>
-              <a:t>Sessione condivisa 17:30</a:t>
+              <a:t>Sessione condivisa 17:00</a:t>
             </a:r>
             <a:endParaRPr lang="en-US" sz="1200" dirty="0"/>
           </a:p>

</xml_diff>

<commit_message>
Slide ChallengEat 8: mentoring privato dalle 16:00 alle 18:30
Co-Authored-By: Claude Sonnet 5.5 <noreply@anthropic.com>
Claude-Session: https://claude.ai/code/session_01MRJktvvjWbxjtNYhpM5dce
</commit_message>
<xml_diff>
--- a/slides/benvenuto.pptx
+++ b/slides/benvenuto.pptx
@@ -124,26 +124,26 @@
   <p:extLst>
     <p:ext uri="{521415D9-36F7-43E2-AB2F-B90AF26B5E84}">
       <p14:sectionLst xmlns:p14="http://schemas.microsoft.com/office/powerpoint/2010/main">
-        <p14:section name="Apertura" id="{45b10f83-e064-4203-2da7-1b31b9889e61}">
+        <p14:section name="Apertura" id="{2c59b51e-ef58-2581-e403-23c4362b9efb}">
           <p14:sldIdLst>
             <p14:sldId id="256"/>
           </p14:sldIdLst>
         </p14:section>
-        <p14:section name="Il percorso" id="{8a184de6-b502-bf21-0d25-5fd9356e93b3}">
+        <p14:section name="Il percorso" id="{a6c5af79-488f-99c2-1b6e-7c06918f485d}">
           <p14:sldIdLst>
             <p14:sldId id="257"/>
             <p14:sldId id="258"/>
             <p14:sldId id="259"/>
           </p14:sldIdLst>
         </p14:section>
-        <p14:section name="Calendario" id="{c3c91e9f-f7e0-dfb5-eda8-838949015565}">
+        <p14:section name="Calendario" id="{025b591a-3174-e866-a026-b7f11562ee9f}">
           <p14:sldIdLst>
             <p14:sldId id="260"/>
             <p14:sldId id="261"/>
             <p14:sldId id="262"/>
           </p14:sldIdLst>
         </p14:section>
-        <p14:section name="Lavoro in gruppo" id="{243660f5-1e72-a30c-3d9f-50cc1a5c30db}">
+        <p14:section name="Lavoro in gruppo" id="{27471359-7c7f-d364-b53a-45eef83af207}">
           <p14:sldIdLst>
             <p14:sldId id="263"/>
             <p14:sldId id="264"/>
@@ -152,14 +152,14 @@
             <p14:sldId id="267"/>
           </p14:sldIdLst>
         </p14:section>
-        <p14:section name="La piattaforma" id="{7449b8dc-a2aa-be3b-2dae-e056a545759a}">
+        <p14:section name="La piattaforma" id="{098feb9b-4104-69b7-ffcd-830044d55bd9}">
           <p14:sldIdLst>
             <p14:sldId id="268"/>
             <p14:sldId id="269"/>
             <p14:sldId id="270"/>
           </p14:sldIdLst>
         </p14:section>
-        <p14:section name="Il valore del percorso" id="{7a54560c-7b57-29c6-f8a6-f8798df4bec2}">
+        <p14:section name="Il valore del percorso" id="{78611efc-e32a-b221-6f43-b09ab4217b6e}">
           <p14:sldIdLst>
             <p14:sldId id="271"/>
             <p14:sldId id="272"/>
@@ -9057,7 +9057,7 @@
                   <a:schemeClr val="tx1"/>
                 </a:solidFill>
               </a:rPr>
-              <a:t>Alle 16:00, 16:30, 17:00 o 17:30, secondo il gruppo</a:t>
+              <a:t>Dalle 16:00 alle 18:30, un turno da 30 minuti per gruppo</a:t>
             </a:r>
             <a:endParaRPr lang="en-US" sz="1800" dirty="0"/>
           </a:p>

</xml_diff>

<commit_message>
Slide ChallengEat 8: fasce orarie di entrambe le giornate nella slide del calendario
Co-Authored-By: Claude Sonnet 5.5 <noreply@anthropic.com>
Claude-Session: https://claude.ai/code/session_01MRJktvvjWbxjtNYhpM5dce
</commit_message>
<xml_diff>
--- a/slides/benvenuto.pptx
+++ b/slides/benvenuto.pptx
@@ -124,26 +124,26 @@
   <p:extLst>
     <p:ext uri="{521415D9-36F7-43E2-AB2F-B90AF26B5E84}">
       <p14:sectionLst xmlns:p14="http://schemas.microsoft.com/office/powerpoint/2010/main">
-        <p14:section name="Apertura" id="{2c59b51e-ef58-2581-e403-23c4362b9efb}">
+        <p14:section name="Apertura" id="{fec91b17-6a4d-a964-4ffd-d9c1f8c68917}">
           <p14:sldIdLst>
             <p14:sldId id="256"/>
           </p14:sldIdLst>
         </p14:section>
-        <p14:section name="Il percorso" id="{a6c5af79-488f-99c2-1b6e-7c06918f485d}">
+        <p14:section name="Il percorso" id="{5ff09fb1-1321-fb99-220b-32e232da70a6}">
           <p14:sldIdLst>
             <p14:sldId id="257"/>
             <p14:sldId id="258"/>
             <p14:sldId id="259"/>
           </p14:sldIdLst>
         </p14:section>
-        <p14:section name="Calendario" id="{025b591a-3174-e866-a026-b7f11562ee9f}">
+        <p14:section name="Calendario" id="{c9a437a2-0d6b-21ae-baf5-aa7761e0e73b}">
           <p14:sldIdLst>
             <p14:sldId id="260"/>
             <p14:sldId id="261"/>
             <p14:sldId id="262"/>
           </p14:sldIdLst>
         </p14:section>
-        <p14:section name="Lavoro in gruppo" id="{27471359-7c7f-d364-b53a-45eef83af207}">
+        <p14:section name="Lavoro in gruppo" id="{b7b7fa42-838f-755c-0cbc-2f98589f4336}">
           <p14:sldIdLst>
             <p14:sldId id="263"/>
             <p14:sldId id="264"/>
@@ -152,14 +152,14 @@
             <p14:sldId id="267"/>
           </p14:sldIdLst>
         </p14:section>
-        <p14:section name="La piattaforma" id="{098feb9b-4104-69b7-ffcd-830044d55bd9}">
+        <p14:section name="La piattaforma" id="{cb062056-19cb-1ea5-7999-85f94f640ca2}">
           <p14:sldIdLst>
             <p14:sldId id="268"/>
             <p14:sldId id="269"/>
             <p14:sldId id="270"/>
           </p14:sldIdLst>
         </p14:section>
-        <p14:section name="Il valore del percorso" id="{78611efc-e32a-b221-6f43-b09ab4217b6e}">
+        <p14:section name="Il valore del percorso" id="{42d28d67-10af-ef3e-dad9-7b0bdefdb216}">
           <p14:sldIdLst>
             <p14:sldId id="271"/>
             <p14:sldId id="272"/>
@@ -9295,7 +9295,7 @@
         <p:spPr>
           <a:xfrm>
             <a:off x="813816" y="1600200"/>
-            <a:ext cx="1951878" cy="3703320"/>
+            <a:ext cx="1951878" cy="3886200"/>
           </a:xfrm>
           <a:prstGeom prst="roundRect">
             <a:avLst>
@@ -9401,11 +9401,11 @@
         <p:spPr>
           <a:xfrm>
             <a:off x="950976" y="2560320"/>
-            <a:ext cx="1677558" cy="1188720"/>
+            <a:ext cx="1677558" cy="1325880"/>
           </a:xfrm>
           <a:prstGeom prst="roundRect">
             <a:avLst>
-              <a:gd name="adj" fmla="val 7692"/>
+              <a:gd name="adj" fmla="val 6897"/>
             </a:avLst>
           </a:prstGeom>
           <a:solidFill>
@@ -9428,7 +9428,7 @@
         <p:spPr>
           <a:xfrm>
             <a:off x="1069848" y="2560320"/>
-            <a:ext cx="1439814" cy="1188720"/>
+            <a:ext cx="1439814" cy="1325880"/>
           </a:xfrm>
           <a:prstGeom prst="rect">
             <a:avLst/>
@@ -9472,12 +9472,26 @@
               <a:buNone/>
             </a:pPr>
             <a:r>
+              <a:rPr lang="en-US" sz="1400" b="1" dirty="0">
+                <a:solidFill>
+                  <a:schemeClr val="bg1"/>
+                </a:solidFill>
+              </a:rPr>
+              <a:t>17:00-18:30</a:t>
+            </a:r>
+            <a:endParaRPr lang="en-US" sz="1200" dirty="0"/>
+          </a:p>
+          <a:p>
+            <a:pPr indent="0" marL="0">
+              <a:buNone/>
+            </a:pPr>
+            <a:r>
               <a:rPr lang="en-US" sz="1200" dirty="0">
                 <a:solidFill>
                   <a:schemeClr val="bg1"/>
                 </a:solidFill>
               </a:rPr>
-              <a:t>Sessione condivisa 17:00</a:t>
+              <a:t>Sessione condivisa</a:t>
             </a:r>
             <a:endParaRPr lang="en-US" sz="1200" dirty="0"/>
           </a:p>
@@ -9491,12 +9505,12 @@
         </p:nvSpPr>
         <p:spPr>
           <a:xfrm>
-            <a:off x="950976" y="3886200"/>
-            <a:ext cx="1677558" cy="1188720"/>
+            <a:off x="950976" y="4023360"/>
+            <a:ext cx="1677558" cy="1325880"/>
           </a:xfrm>
           <a:prstGeom prst="roundRect">
             <a:avLst>
-              <a:gd name="adj" fmla="val 7692"/>
+              <a:gd name="adj" fmla="val 6897"/>
             </a:avLst>
           </a:prstGeom>
           <a:solidFill>
@@ -9518,8 +9532,8 @@
         </p:nvSpPr>
         <p:spPr>
           <a:xfrm>
-            <a:off x="1069848" y="3886200"/>
-            <a:ext cx="1439814" cy="1188720"/>
+            <a:off x="1069848" y="4023360"/>
+            <a:ext cx="1439814" cy="1325880"/>
           </a:xfrm>
           <a:prstGeom prst="rect">
             <a:avLst/>
@@ -9555,6 +9569,20 @@
                 </a:solidFill>
               </a:rPr>
               <a:t>16 ottobre</a:t>
+            </a:r>
+            <a:endParaRPr lang="en-US" sz="1200" dirty="0"/>
+          </a:p>
+          <a:p>
+            <a:pPr indent="0" marL="0">
+              <a:buNone/>
+            </a:pPr>
+            <a:r>
+              <a:rPr lang="en-US" sz="1400" b="1" dirty="0">
+                <a:solidFill>
+                  <a:schemeClr val="tx1"/>
+                </a:solidFill>
+              </a:rPr>
+              <a:t>16:00-18:30</a:t>
             </a:r>
             <a:endParaRPr lang="en-US" sz="1200" dirty="0"/>
           </a:p>
@@ -9583,7 +9611,7 @@
         <p:spPr>
           <a:xfrm>
             <a:off x="2966862" y="1600200"/>
-            <a:ext cx="1951878" cy="3703320"/>
+            <a:ext cx="1951878" cy="3886200"/>
           </a:xfrm>
           <a:prstGeom prst="roundRect">
             <a:avLst>
@@ -9689,11 +9717,11 @@
         <p:spPr>
           <a:xfrm>
             <a:off x="3104022" y="2560320"/>
-            <a:ext cx="1677558" cy="1188720"/>
+            <a:ext cx="1677558" cy="1325880"/>
           </a:xfrm>
           <a:prstGeom prst="roundRect">
             <a:avLst>
-              <a:gd name="adj" fmla="val 7692"/>
+              <a:gd name="adj" fmla="val 6897"/>
             </a:avLst>
           </a:prstGeom>
           <a:solidFill>
@@ -9716,7 +9744,7 @@
         <p:spPr>
           <a:xfrm>
             <a:off x="3222894" y="2560320"/>
-            <a:ext cx="1439814" cy="1188720"/>
+            <a:ext cx="1439814" cy="1325880"/>
           </a:xfrm>
           <a:prstGeom prst="rect">
             <a:avLst/>
@@ -9760,12 +9788,26 @@
               <a:buNone/>
             </a:pPr>
             <a:r>
+              <a:rPr lang="en-US" sz="1400" b="1" dirty="0">
+                <a:solidFill>
+                  <a:schemeClr val="bg1"/>
+                </a:solidFill>
+              </a:rPr>
+              <a:t>17:00-18:30</a:t>
+            </a:r>
+            <a:endParaRPr lang="en-US" sz="1200" dirty="0"/>
+          </a:p>
+          <a:p>
+            <a:pPr indent="0" marL="0">
+              <a:buNone/>
+            </a:pPr>
+            <a:r>
               <a:rPr lang="en-US" sz="1200" dirty="0">
                 <a:solidFill>
                   <a:schemeClr val="bg1"/>
                 </a:solidFill>
               </a:rPr>
-              <a:t>Sessione condivisa 17:00</a:t>
+              <a:t>Sessione condivisa</a:t>
             </a:r>
             <a:endParaRPr lang="en-US" sz="1200" dirty="0"/>
           </a:p>
@@ -9779,12 +9821,12 @@
         </p:nvSpPr>
         <p:spPr>
           <a:xfrm>
-            <a:off x="3104022" y="3886200"/>
-            <a:ext cx="1677558" cy="1188720"/>
+            <a:off x="3104022" y="4023360"/>
+            <a:ext cx="1677558" cy="1325880"/>
           </a:xfrm>
           <a:prstGeom prst="roundRect">
             <a:avLst>
-              <a:gd name="adj" fmla="val 7692"/>
+              <a:gd name="adj" fmla="val 6897"/>
             </a:avLst>
           </a:prstGeom>
           <a:solidFill>
@@ -9806,8 +9848,8 @@
         </p:nvSpPr>
         <p:spPr>
           <a:xfrm>
-            <a:off x="3222894" y="3886200"/>
-            <a:ext cx="1439814" cy="1188720"/>
+            <a:off x="3222894" y="4023360"/>
+            <a:ext cx="1439814" cy="1325880"/>
           </a:xfrm>
           <a:prstGeom prst="rect">
             <a:avLst/>
@@ -9843,6 +9885,20 @@
                 </a:solidFill>
               </a:rPr>
               <a:t>23 ottobre</a:t>
+            </a:r>
+            <a:endParaRPr lang="en-US" sz="1200" dirty="0"/>
+          </a:p>
+          <a:p>
+            <a:pPr indent="0" marL="0">
+              <a:buNone/>
+            </a:pPr>
+            <a:r>
+              <a:rPr lang="en-US" sz="1400" b="1" dirty="0">
+                <a:solidFill>
+                  <a:schemeClr val="tx1"/>
+                </a:solidFill>
+              </a:rPr>
+              <a:t>16:00-18:30</a:t>
             </a:r>
             <a:endParaRPr lang="en-US" sz="1200" dirty="0"/>
           </a:p>
@@ -9871,7 +9927,7 @@
         <p:spPr>
           <a:xfrm>
             <a:off x="5119908" y="1600200"/>
-            <a:ext cx="1951878" cy="3703320"/>
+            <a:ext cx="1951878" cy="3886200"/>
           </a:xfrm>
           <a:prstGeom prst="roundRect">
             <a:avLst>
@@ -9977,11 +10033,11 @@
         <p:spPr>
           <a:xfrm>
             <a:off x="5257068" y="2560320"/>
-            <a:ext cx="1677558" cy="1188720"/>
+            <a:ext cx="1677558" cy="1325880"/>
           </a:xfrm>
           <a:prstGeom prst="roundRect">
             <a:avLst>
-              <a:gd name="adj" fmla="val 7692"/>
+              <a:gd name="adj" fmla="val 6897"/>
             </a:avLst>
           </a:prstGeom>
           <a:solidFill>
@@ -10004,7 +10060,7 @@
         <p:spPr>
           <a:xfrm>
             <a:off x="5375940" y="2560320"/>
-            <a:ext cx="1439814" cy="1188720"/>
+            <a:ext cx="1439814" cy="1325880"/>
           </a:xfrm>
           <a:prstGeom prst="rect">
             <a:avLst/>
@@ -10048,12 +10104,26 @@
               <a:buNone/>
             </a:pPr>
             <a:r>
+              <a:rPr lang="en-US" sz="1400" b="1" dirty="0">
+                <a:solidFill>
+                  <a:schemeClr val="bg1"/>
+                </a:solidFill>
+              </a:rPr>
+              <a:t>17:00-18:30</a:t>
+            </a:r>
+            <a:endParaRPr lang="en-US" sz="1200" dirty="0"/>
+          </a:p>
+          <a:p>
+            <a:pPr indent="0" marL="0">
+              <a:buNone/>
+            </a:pPr>
+            <a:r>
               <a:rPr lang="en-US" sz="1200" dirty="0">
                 <a:solidFill>
                   <a:schemeClr val="bg1"/>
                 </a:solidFill>
               </a:rPr>
-              <a:t>Sessione condivisa 17:00</a:t>
+              <a:t>Sessione condivisa</a:t>
             </a:r>
             <a:endParaRPr lang="en-US" sz="1200" dirty="0"/>
           </a:p>
@@ -10067,12 +10137,12 @@
         </p:nvSpPr>
         <p:spPr>
           <a:xfrm>
-            <a:off x="5257068" y="3886200"/>
-            <a:ext cx="1677558" cy="1188720"/>
+            <a:off x="5257068" y="4023360"/>
+            <a:ext cx="1677558" cy="1325880"/>
           </a:xfrm>
           <a:prstGeom prst="roundRect">
             <a:avLst>
-              <a:gd name="adj" fmla="val 7692"/>
+              <a:gd name="adj" fmla="val 6897"/>
             </a:avLst>
           </a:prstGeom>
           <a:solidFill>
@@ -10094,8 +10164,8 @@
         </p:nvSpPr>
         <p:spPr>
           <a:xfrm>
-            <a:off x="5375940" y="3886200"/>
-            <a:ext cx="1439814" cy="1188720"/>
+            <a:off x="5375940" y="4023360"/>
+            <a:ext cx="1439814" cy="1325880"/>
           </a:xfrm>
           <a:prstGeom prst="rect">
             <a:avLst/>
@@ -10131,6 +10201,20 @@
                 </a:solidFill>
               </a:rPr>
               <a:t>30 ottobre</a:t>
+            </a:r>
+            <a:endParaRPr lang="en-US" sz="1200" dirty="0"/>
+          </a:p>
+          <a:p>
+            <a:pPr indent="0" marL="0">
+              <a:buNone/>
+            </a:pPr>
+            <a:r>
+              <a:rPr lang="en-US" sz="1400" b="1" dirty="0">
+                <a:solidFill>
+                  <a:schemeClr val="tx1"/>
+                </a:solidFill>
+              </a:rPr>
+              <a:t>16:00-18:30</a:t>
             </a:r>
             <a:endParaRPr lang="en-US" sz="1200" dirty="0"/>
           </a:p>
@@ -10159,7 +10243,7 @@
         <p:spPr>
           <a:xfrm>
             <a:off x="7272955" y="1600200"/>
-            <a:ext cx="1951878" cy="3703320"/>
+            <a:ext cx="1951878" cy="3886200"/>
           </a:xfrm>
           <a:prstGeom prst="roundRect">
             <a:avLst>
@@ -10265,11 +10349,11 @@
         <p:spPr>
           <a:xfrm>
             <a:off x="7410115" y="2560320"/>
-            <a:ext cx="1677558" cy="1188720"/>
+            <a:ext cx="1677558" cy="1325880"/>
           </a:xfrm>
           <a:prstGeom prst="roundRect">
             <a:avLst>
-              <a:gd name="adj" fmla="val 7692"/>
+              <a:gd name="adj" fmla="val 6897"/>
             </a:avLst>
           </a:prstGeom>
           <a:solidFill>
@@ -10292,7 +10376,7 @@
         <p:spPr>
           <a:xfrm>
             <a:off x="7528987" y="2560320"/>
-            <a:ext cx="1439814" cy="1188720"/>
+            <a:ext cx="1439814" cy="1325880"/>
           </a:xfrm>
           <a:prstGeom prst="rect">
             <a:avLst/>
@@ -10336,12 +10420,26 @@
               <a:buNone/>
             </a:pPr>
             <a:r>
+              <a:rPr lang="en-US" sz="1400" b="1" dirty="0">
+                <a:solidFill>
+                  <a:schemeClr val="bg1"/>
+                </a:solidFill>
+              </a:rPr>
+              <a:t>17:00-18:30</a:t>
+            </a:r>
+            <a:endParaRPr lang="en-US" sz="1200" dirty="0"/>
+          </a:p>
+          <a:p>
+            <a:pPr indent="0" marL="0">
+              <a:buNone/>
+            </a:pPr>
+            <a:r>
               <a:rPr lang="en-US" sz="1200" dirty="0">
                 <a:solidFill>
                   <a:schemeClr val="bg1"/>
                 </a:solidFill>
               </a:rPr>
-              <a:t>Sessione condivisa 17:00</a:t>
+              <a:t>Sessione condivisa</a:t>
             </a:r>
             <a:endParaRPr lang="en-US" sz="1200" dirty="0"/>
           </a:p>
@@ -10355,12 +10453,12 @@
         </p:nvSpPr>
         <p:spPr>
           <a:xfrm>
-            <a:off x="7410115" y="3886200"/>
-            <a:ext cx="1677558" cy="1188720"/>
+            <a:off x="7410115" y="4023360"/>
+            <a:ext cx="1677558" cy="1325880"/>
           </a:xfrm>
           <a:prstGeom prst="roundRect">
             <a:avLst>
-              <a:gd name="adj" fmla="val 7692"/>
+              <a:gd name="adj" fmla="val 6897"/>
             </a:avLst>
           </a:prstGeom>
           <a:solidFill>
@@ -10382,8 +10480,8 @@
         </p:nvSpPr>
         <p:spPr>
           <a:xfrm>
-            <a:off x="7528987" y="3886200"/>
-            <a:ext cx="1439814" cy="1188720"/>
+            <a:off x="7528987" y="4023360"/>
+            <a:ext cx="1439814" cy="1325880"/>
           </a:xfrm>
           <a:prstGeom prst="rect">
             <a:avLst/>
@@ -10419,6 +10517,20 @@
                 </a:solidFill>
               </a:rPr>
               <a:t>6 novembre</a:t>
+            </a:r>
+            <a:endParaRPr lang="en-US" sz="1200" dirty="0"/>
+          </a:p>
+          <a:p>
+            <a:pPr indent="0" marL="0">
+              <a:buNone/>
+            </a:pPr>
+            <a:r>
+              <a:rPr lang="en-US" sz="1400" b="1" dirty="0">
+                <a:solidFill>
+                  <a:schemeClr val="tx1"/>
+                </a:solidFill>
+              </a:rPr>
+              <a:t>16:00-18:30</a:t>
             </a:r>
             <a:endParaRPr lang="en-US" sz="1200" dirty="0"/>
           </a:p>
@@ -10447,7 +10559,7 @@
         <p:spPr>
           <a:xfrm>
             <a:off x="9426001" y="1600200"/>
-            <a:ext cx="1951878" cy="3703320"/>
+            <a:ext cx="1951878" cy="3886200"/>
           </a:xfrm>
           <a:prstGeom prst="roundRect">
             <a:avLst>
@@ -10553,11 +10665,11 @@
         <p:spPr>
           <a:xfrm>
             <a:off x="9563161" y="2560320"/>
-            <a:ext cx="1677558" cy="1188720"/>
+            <a:ext cx="1677558" cy="1325880"/>
           </a:xfrm>
           <a:prstGeom prst="roundRect">
             <a:avLst>
-              <a:gd name="adj" fmla="val 7692"/>
+              <a:gd name="adj" fmla="val 6897"/>
             </a:avLst>
           </a:prstGeom>
           <a:solidFill>
@@ -10580,7 +10692,7 @@
         <p:spPr>
           <a:xfrm>
             <a:off x="9682033" y="2560320"/>
-            <a:ext cx="1439814" cy="1188720"/>
+            <a:ext cx="1439814" cy="1325880"/>
           </a:xfrm>
           <a:prstGeom prst="rect">
             <a:avLst/>
@@ -10624,12 +10736,26 @@
               <a:buNone/>
             </a:pPr>
             <a:r>
+              <a:rPr lang="en-US" sz="1400" b="1" dirty="0">
+                <a:solidFill>
+                  <a:schemeClr val="bg1"/>
+                </a:solidFill>
+              </a:rPr>
+              <a:t>17:00-18:30</a:t>
+            </a:r>
+            <a:endParaRPr lang="en-US" sz="1200" dirty="0"/>
+          </a:p>
+          <a:p>
+            <a:pPr indent="0" marL="0">
+              <a:buNone/>
+            </a:pPr>
+            <a:r>
               <a:rPr lang="en-US" sz="1200" dirty="0">
                 <a:solidFill>
                   <a:schemeClr val="bg1"/>
                 </a:solidFill>
               </a:rPr>
-              <a:t>Sessione condivisa 17:00</a:t>
+              <a:t>Sessione condivisa</a:t>
             </a:r>
             <a:endParaRPr lang="en-US" sz="1200" dirty="0"/>
           </a:p>
@@ -10643,12 +10769,12 @@
         </p:nvSpPr>
         <p:spPr>
           <a:xfrm>
-            <a:off x="9563161" y="3886200"/>
-            <a:ext cx="1677558" cy="1188720"/>
+            <a:off x="9563161" y="4023360"/>
+            <a:ext cx="1677558" cy="1325880"/>
           </a:xfrm>
           <a:prstGeom prst="roundRect">
             <a:avLst>
-              <a:gd name="adj" fmla="val 7692"/>
+              <a:gd name="adj" fmla="val 6897"/>
             </a:avLst>
           </a:prstGeom>
           <a:solidFill>
@@ -10670,8 +10796,8 @@
         </p:nvSpPr>
         <p:spPr>
           <a:xfrm>
-            <a:off x="9682033" y="3886200"/>
-            <a:ext cx="1439814" cy="1188720"/>
+            <a:off x="9682033" y="4023360"/>
+            <a:ext cx="1439814" cy="1325880"/>
           </a:xfrm>
           <a:prstGeom prst="rect">
             <a:avLst/>
@@ -10707,6 +10833,20 @@
                 </a:solidFill>
               </a:rPr>
               <a:t>13 novembre</a:t>
+            </a:r>
+            <a:endParaRPr lang="en-US" sz="1200" dirty="0"/>
+          </a:p>
+          <a:p>
+            <a:pPr indent="0" marL="0">
+              <a:buNone/>
+            </a:pPr>
+            <a:r>
+              <a:rPr lang="en-US" sz="1400" b="1" dirty="0">
+                <a:solidFill>
+                  <a:schemeClr val="tx1"/>
+                </a:solidFill>
+              </a:rPr>
+              <a:t>16:00-18:30</a:t>
             </a:r>
             <a:endParaRPr lang="en-US" sz="1200" dirty="0"/>
           </a:p>
@@ -10734,7 +10874,7 @@
         </p:nvSpPr>
         <p:spPr>
           <a:xfrm>
-            <a:off x="813816" y="5486400"/>
+            <a:off x="813816" y="5623560"/>
             <a:ext cx="10564063" cy="566928"/>
           </a:xfrm>
           <a:prstGeom prst="roundRect">
@@ -10761,7 +10901,7 @@
         </p:nvSpPr>
         <p:spPr>
           <a:xfrm>
-            <a:off x="1042416" y="5486400"/>
+            <a:off x="1042416" y="5623560"/>
             <a:ext cx="10106863" cy="566928"/>
           </a:xfrm>
           <a:prstGeom prst="rect">

</xml_diff>

<commit_message>
Slide ChallengEat 8: martedì con i partner tecnici, venerdì con i mentor aziendali
Co-Authored-By: Claude Sonnet 5.5 <noreply@anthropic.com>
Claude-Session: https://claude.ai/code/session_01MRJktvvjWbxjtNYhpM5dce
</commit_message>
<xml_diff>
--- a/slides/benvenuto.pptx
+++ b/slides/benvenuto.pptx
@@ -124,26 +124,26 @@
   <p:extLst>
     <p:ext uri="{521415D9-36F7-43E2-AB2F-B90AF26B5E84}">
       <p14:sectionLst xmlns:p14="http://schemas.microsoft.com/office/powerpoint/2010/main">
-        <p14:section name="Apertura" id="{fec91b17-6a4d-a964-4ffd-d9c1f8c68917}">
+        <p14:section name="Apertura" id="{a7fdd7ea-b1b5-9566-11a7-6eb508c4be18}">
           <p14:sldIdLst>
             <p14:sldId id="256"/>
           </p14:sldIdLst>
         </p14:section>
-        <p14:section name="Il percorso" id="{5ff09fb1-1321-fb99-220b-32e232da70a6}">
+        <p14:section name="Il percorso" id="{798686ca-92da-4e76-b6ad-e4dd4d28085a}">
           <p14:sldIdLst>
             <p14:sldId id="257"/>
             <p14:sldId id="258"/>
             <p14:sldId id="259"/>
           </p14:sldIdLst>
         </p14:section>
-        <p14:section name="Calendario" id="{c9a437a2-0d6b-21ae-baf5-aa7761e0e73b}">
+        <p14:section name="Calendario" id="{8ddf9a05-58f9-81ae-236a-78dcd33b3ee6}">
           <p14:sldIdLst>
             <p14:sldId id="260"/>
             <p14:sldId id="261"/>
             <p14:sldId id="262"/>
           </p14:sldIdLst>
         </p14:section>
-        <p14:section name="Lavoro in gruppo" id="{b7b7fa42-838f-755c-0cbc-2f98589f4336}">
+        <p14:section name="Lavoro in gruppo" id="{6fa50785-949c-ac96-0c82-b4ad2c5f40c8}">
           <p14:sldIdLst>
             <p14:sldId id="263"/>
             <p14:sldId id="264"/>
@@ -152,14 +152,14 @@
             <p14:sldId id="267"/>
           </p14:sldIdLst>
         </p14:section>
-        <p14:section name="La piattaforma" id="{cb062056-19cb-1ea5-7999-85f94f640ca2}">
+        <p14:section name="La piattaforma" id="{81a15c8b-d37a-947e-8755-e436f2541132}">
           <p14:sldIdLst>
             <p14:sldId id="268"/>
             <p14:sldId id="269"/>
             <p14:sldId id="270"/>
           </p14:sldIdLst>
         </p14:section>
-        <p14:section name="Il valore del percorso" id="{42d28d67-10af-ef3e-dad9-7b0bdefdb216}">
+        <p14:section name="Il valore del percorso" id="{dca74118-7369-0e44-7c0e-7410a161f84c}">
           <p14:sldIdLst>
             <p14:sldId id="271"/>
             <p14:sldId id="272"/>
@@ -4906,7 +4906,7 @@
                   <a:schemeClr val="tx1"/>
                 </a:solidFill>
               </a:rPr>
-              <a:t>Nelle sessioni condivise potete portare anche dubbi che riguardano tutti i gruppi.</a:t>
+              <a:t>Il martedì le domande vanno ai partner tecnici, il venerdì al mentor aziendale: preparatele di conseguenza.</a:t>
             </a:r>
             <a:endParaRPr lang="en-US" sz="1600" dirty="0"/>
           </a:p>
@@ -8857,7 +8857,7 @@
                   <a:schemeClr val="tx1"/>
                 </a:solidFill>
               </a:rPr>
-              <a:t>Con i partner tecnici e i mentor</a:t>
+              <a:t>Solo con i partner tecnici: MV Consulting e Wiseside</a:t>
             </a:r>
             <a:endParaRPr lang="en-US" sz="1800" dirty="0"/>
           </a:p>
@@ -9039,7 +9039,7 @@
                   <a:schemeClr val="tx1"/>
                 </a:solidFill>
               </a:rPr>
-              <a:t>Il vostro gruppo con il mentor dell'azienda</a:t>
+              <a:t>Il vostro gruppo con il mentor aziendale di riferimento</a:t>
             </a:r>
             <a:endParaRPr lang="en-US" sz="1800" dirty="0"/>
           </a:p>
@@ -9491,7 +9491,7 @@
                   <a:schemeClr val="bg1"/>
                 </a:solidFill>
               </a:rPr>
-              <a:t>Sessione condivisa</a:t>
+              <a:t>Condivisa, con i partner tecnici</a:t>
             </a:r>
             <a:endParaRPr lang="en-US" sz="1200" dirty="0"/>
           </a:p>
@@ -9596,7 +9596,7 @@
                   <a:schemeClr val="tx1"/>
                 </a:solidFill>
               </a:rPr>
-              <a:t>Mentoring privato</a:t>
+              <a:t>Privata, con il mentor aziendale</a:t>
             </a:r>
             <a:endParaRPr lang="en-US" sz="1200" dirty="0"/>
           </a:p>
@@ -9807,7 +9807,7 @@
                   <a:schemeClr val="bg1"/>
                 </a:solidFill>
               </a:rPr>
-              <a:t>Sessione condivisa</a:t>
+              <a:t>Condivisa, con i partner tecnici</a:t>
             </a:r>
             <a:endParaRPr lang="en-US" sz="1200" dirty="0"/>
           </a:p>
@@ -9912,7 +9912,7 @@
                   <a:schemeClr val="tx1"/>
                 </a:solidFill>
               </a:rPr>
-              <a:t>Mentoring privato</a:t>
+              <a:t>Privata, con il mentor aziendale</a:t>
             </a:r>
             <a:endParaRPr lang="en-US" sz="1200" dirty="0"/>
           </a:p>
@@ -10123,7 +10123,7 @@
                   <a:schemeClr val="bg1"/>
                 </a:solidFill>
               </a:rPr>
-              <a:t>Sessione condivisa</a:t>
+              <a:t>Condivisa, con i partner tecnici</a:t>
             </a:r>
             <a:endParaRPr lang="en-US" sz="1200" dirty="0"/>
           </a:p>
@@ -10228,7 +10228,7 @@
                   <a:schemeClr val="tx1"/>
                 </a:solidFill>
               </a:rPr>
-              <a:t>Mentoring privato</a:t>
+              <a:t>Privata, con il mentor aziendale</a:t>
             </a:r>
             <a:endParaRPr lang="en-US" sz="1200" dirty="0"/>
           </a:p>
@@ -10439,7 +10439,7 @@
                   <a:schemeClr val="bg1"/>
                 </a:solidFill>
               </a:rPr>
-              <a:t>Sessione condivisa</a:t>
+              <a:t>Condivisa, con i partner tecnici</a:t>
             </a:r>
             <a:endParaRPr lang="en-US" sz="1200" dirty="0"/>
           </a:p>
@@ -10544,7 +10544,7 @@
                   <a:schemeClr val="tx1"/>
                 </a:solidFill>
               </a:rPr>
-              <a:t>Mentoring privato</a:t>
+              <a:t>Privata, con il mentor aziendale</a:t>
             </a:r>
             <a:endParaRPr lang="en-US" sz="1200" dirty="0"/>
           </a:p>
@@ -10755,7 +10755,7 @@
                   <a:schemeClr val="bg1"/>
                 </a:solidFill>
               </a:rPr>
-              <a:t>Sessione condivisa</a:t>
+              <a:t>Condivisa, con i partner tecnici</a:t>
             </a:r>
             <a:endParaRPr lang="en-US" sz="1200" dirty="0"/>
           </a:p>
@@ -10860,7 +10860,7 @@
                   <a:schemeClr val="tx1"/>
                 </a:solidFill>
               </a:rPr>
-              <a:t>Mentoring privato</a:t>
+              <a:t>Privata, con il mentor aziendale</a:t>
             </a:r>
             <a:endParaRPr lang="en-US" sz="1200" dirty="0"/>
           </a:p>

</xml_diff>

<commit_message>
Slide ChallengEat 8: sessione privata della settimana 2 il 22 ottobre
Co-Authored-By: Claude Sonnet 5.5 <noreply@anthropic.com>
Claude-Session: https://claude.ai/code/session_01MRJktvvjWbxjtNYhpM5dce
</commit_message>
<xml_diff>
--- a/slides/benvenuto.pptx
+++ b/slides/benvenuto.pptx
@@ -124,26 +124,26 @@
   <p:extLst>
     <p:ext uri="{521415D9-36F7-43E2-AB2F-B90AF26B5E84}">
       <p14:sectionLst xmlns:p14="http://schemas.microsoft.com/office/powerpoint/2010/main">
-        <p14:section name="Apertura" id="{a7fdd7ea-b1b5-9566-11a7-6eb508c4be18}">
+        <p14:section name="Apertura" id="{1f7d4d53-9867-f527-4815-06c28a4c5ffa}">
           <p14:sldIdLst>
             <p14:sldId id="256"/>
           </p14:sldIdLst>
         </p14:section>
-        <p14:section name="Il percorso" id="{798686ca-92da-4e76-b6ad-e4dd4d28085a}">
+        <p14:section name="Il percorso" id="{22dbd357-9df8-c5b6-6176-0ab24df04635}">
           <p14:sldIdLst>
             <p14:sldId id="257"/>
             <p14:sldId id="258"/>
             <p14:sldId id="259"/>
           </p14:sldIdLst>
         </p14:section>
-        <p14:section name="Calendario" id="{8ddf9a05-58f9-81ae-236a-78dcd33b3ee6}">
+        <p14:section name="Calendario" id="{74cae037-f2dd-0cad-8dd3-22b2017af034}">
           <p14:sldIdLst>
             <p14:sldId id="260"/>
             <p14:sldId id="261"/>
             <p14:sldId id="262"/>
           </p14:sldIdLst>
         </p14:section>
-        <p14:section name="Lavoro in gruppo" id="{6fa50785-949c-ac96-0c82-b4ad2c5f40c8}">
+        <p14:section name="Lavoro in gruppo" id="{000ec0cd-f917-302a-4dad-c1897ff345e3}">
           <p14:sldIdLst>
             <p14:sldId id="263"/>
             <p14:sldId id="264"/>
@@ -152,14 +152,14 @@
             <p14:sldId id="267"/>
           </p14:sldIdLst>
         </p14:section>
-        <p14:section name="La piattaforma" id="{81a15c8b-d37a-947e-8755-e436f2541132}">
+        <p14:section name="La piattaforma" id="{82c0de59-ef51-c174-2ef5-6095ae2a7bbc}">
           <p14:sldIdLst>
             <p14:sldId id="268"/>
             <p14:sldId id="269"/>
             <p14:sldId id="270"/>
           </p14:sldIdLst>
         </p14:section>
-        <p14:section name="Il valore del percorso" id="{dca74118-7369-0e44-7c0e-7410a161f84c}">
+        <p14:section name="Il valore del percorso" id="{3dbcae3e-481e-f96f-4e91-2ad7bde75ab6}">
           <p14:sldIdLst>
             <p14:sldId id="271"/>
             <p14:sldId id="272"/>
@@ -9870,7 +9870,7 @@
                   <a:schemeClr val="accent5"/>
                 </a:solidFill>
               </a:rPr>
-              <a:t>Venerdì</a:t>
+              <a:t>Giovedì</a:t>
             </a:r>
             <a:endParaRPr lang="en-US" sz="1200" dirty="0"/>
           </a:p>
@@ -9884,7 +9884,7 @@
                   <a:schemeClr val="tx1"/>
                 </a:solidFill>
               </a:rPr>
-              <a:t>23 ottobre</a:t>
+              <a:t>22 ottobre</a:t>
             </a:r>
             <a:endParaRPr lang="en-US" sz="1200" dirty="0"/>
           </a:p>

</xml_diff>